<commit_message>
cut to 7 slides
</commit_message>
<xml_diff>
--- a/images/copernican_revolution.pptx
+++ b/images/copernican_revolution.pptx
@@ -7,6 +7,8 @@
   <p:sldIdLst>
     <p:sldId id="257" r:id="rId2"/>
     <p:sldId id="258" r:id="rId3"/>
+    <p:sldId id="260" r:id="rId4"/>
+    <p:sldId id="259" r:id="rId5"/>
   </p:sldIdLst>
   <p:sldSz cx="12192000" cy="6858000"/>
   <p:notesSz cx="6858000" cy="9144000"/>
@@ -260,7 +262,7 @@
           <a:p>
             <a:fld id="{8BEA2FD7-9478-4A9C-B4E3-5FBF9F61798F}" type="datetimeFigureOut">
               <a:rPr lang="en-GB" smtClean="0"/>
-              <a:t>29/07/2024</a:t>
+              <a:t>28/08/2025</a:t>
             </a:fld>
             <a:endParaRPr lang="en-GB"/>
           </a:p>
@@ -458,7 +460,7 @@
           <a:p>
             <a:fld id="{8BEA2FD7-9478-4A9C-B4E3-5FBF9F61798F}" type="datetimeFigureOut">
               <a:rPr lang="en-GB" smtClean="0"/>
-              <a:t>29/07/2024</a:t>
+              <a:t>28/08/2025</a:t>
             </a:fld>
             <a:endParaRPr lang="en-GB"/>
           </a:p>
@@ -666,7 +668,7 @@
           <a:p>
             <a:fld id="{8BEA2FD7-9478-4A9C-B4E3-5FBF9F61798F}" type="datetimeFigureOut">
               <a:rPr lang="en-GB" smtClean="0"/>
-              <a:t>29/07/2024</a:t>
+              <a:t>28/08/2025</a:t>
             </a:fld>
             <a:endParaRPr lang="en-GB"/>
           </a:p>
@@ -864,7 +866,7 @@
           <a:p>
             <a:fld id="{8BEA2FD7-9478-4A9C-B4E3-5FBF9F61798F}" type="datetimeFigureOut">
               <a:rPr lang="en-GB" smtClean="0"/>
-              <a:t>29/07/2024</a:t>
+              <a:t>28/08/2025</a:t>
             </a:fld>
             <a:endParaRPr lang="en-GB"/>
           </a:p>
@@ -1139,7 +1141,7 @@
           <a:p>
             <a:fld id="{8BEA2FD7-9478-4A9C-B4E3-5FBF9F61798F}" type="datetimeFigureOut">
               <a:rPr lang="en-GB" smtClean="0"/>
-              <a:t>29/07/2024</a:t>
+              <a:t>28/08/2025</a:t>
             </a:fld>
             <a:endParaRPr lang="en-GB"/>
           </a:p>
@@ -1404,7 +1406,7 @@
           <a:p>
             <a:fld id="{8BEA2FD7-9478-4A9C-B4E3-5FBF9F61798F}" type="datetimeFigureOut">
               <a:rPr lang="en-GB" smtClean="0"/>
-              <a:t>29/07/2024</a:t>
+              <a:t>28/08/2025</a:t>
             </a:fld>
             <a:endParaRPr lang="en-GB"/>
           </a:p>
@@ -1816,7 +1818,7 @@
           <a:p>
             <a:fld id="{8BEA2FD7-9478-4A9C-B4E3-5FBF9F61798F}" type="datetimeFigureOut">
               <a:rPr lang="en-GB" smtClean="0"/>
-              <a:t>29/07/2024</a:t>
+              <a:t>28/08/2025</a:t>
             </a:fld>
             <a:endParaRPr lang="en-GB"/>
           </a:p>
@@ -1957,7 +1959,7 @@
           <a:p>
             <a:fld id="{8BEA2FD7-9478-4A9C-B4E3-5FBF9F61798F}" type="datetimeFigureOut">
               <a:rPr lang="en-GB" smtClean="0"/>
-              <a:t>29/07/2024</a:t>
+              <a:t>28/08/2025</a:t>
             </a:fld>
             <a:endParaRPr lang="en-GB"/>
           </a:p>
@@ -2070,7 +2072,7 @@
           <a:p>
             <a:fld id="{8BEA2FD7-9478-4A9C-B4E3-5FBF9F61798F}" type="datetimeFigureOut">
               <a:rPr lang="en-GB" smtClean="0"/>
-              <a:t>29/07/2024</a:t>
+              <a:t>28/08/2025</a:t>
             </a:fld>
             <a:endParaRPr lang="en-GB"/>
           </a:p>
@@ -2381,7 +2383,7 @@
           <a:p>
             <a:fld id="{8BEA2FD7-9478-4A9C-B4E3-5FBF9F61798F}" type="datetimeFigureOut">
               <a:rPr lang="en-GB" smtClean="0"/>
-              <a:t>29/07/2024</a:t>
+              <a:t>28/08/2025</a:t>
             </a:fld>
             <a:endParaRPr lang="en-GB"/>
           </a:p>
@@ -2669,7 +2671,7 @@
           <a:p>
             <a:fld id="{8BEA2FD7-9478-4A9C-B4E3-5FBF9F61798F}" type="datetimeFigureOut">
               <a:rPr lang="en-GB" smtClean="0"/>
-              <a:t>29/07/2024</a:t>
+              <a:t>28/08/2025</a:t>
             </a:fld>
             <a:endParaRPr lang="en-GB"/>
           </a:p>
@@ -2910,7 +2912,7 @@
           <a:p>
             <a:fld id="{8BEA2FD7-9478-4A9C-B4E3-5FBF9F61798F}" type="datetimeFigureOut">
               <a:rPr lang="en-GB" smtClean="0"/>
-              <a:t>29/07/2024</a:t>
+              <a:t>28/08/2025</a:t>
             </a:fld>
             <a:endParaRPr lang="en-GB"/>
           </a:p>
@@ -5041,6 +5043,743 @@
 </p:sld>
 </file>
 
+<file path=ppt/slides/slide3.xml><?xml version="1.0" encoding="utf-8"?>
+<p:sld xmlns:a="http://schemas.openxmlformats.org/drawingml/2006/main" xmlns:r="http://schemas.openxmlformats.org/officeDocument/2006/relationships" xmlns:p="http://schemas.openxmlformats.org/presentationml/2006/main">
+  <p:cSld>
+    <p:spTree>
+      <p:nvGrpSpPr>
+        <p:cNvPr id="1" name="">
+          <a:extLst>
+            <a:ext uri="{FF2B5EF4-FFF2-40B4-BE49-F238E27FC236}">
+              <a16:creationId xmlns:a16="http://schemas.microsoft.com/office/drawing/2014/main" id="{7B5850C7-20AE-388F-F901-665C8BBE2116}"/>
+            </a:ext>
+          </a:extLst>
+        </p:cNvPr>
+        <p:cNvGrpSpPr/>
+        <p:nvPr/>
+      </p:nvGrpSpPr>
+      <p:grpSpPr>
+        <a:xfrm>
+          <a:off x="0" y="0"/>
+          <a:ext cx="0" cy="0"/>
+          <a:chOff x="0" y="0"/>
+          <a:chExt cx="0" cy="0"/>
+        </a:xfrm>
+      </p:grpSpPr>
+      <p:sp>
+        <p:nvSpPr>
+          <p:cNvPr id="13" name="Flowchart: Connector 12">
+            <a:extLst>
+              <a:ext uri="{FF2B5EF4-FFF2-40B4-BE49-F238E27FC236}">
+                <a16:creationId xmlns:a16="http://schemas.microsoft.com/office/drawing/2014/main" id="{6B2CA055-FF2A-0C56-D029-081737285F7E}"/>
+              </a:ext>
+            </a:extLst>
+          </p:cNvPr>
+          <p:cNvSpPr/>
+          <p:nvPr/>
+        </p:nvSpPr>
+        <p:spPr>
+          <a:xfrm>
+            <a:off x="1691588" y="2452777"/>
+            <a:ext cx="3169009" cy="3328988"/>
+          </a:xfrm>
+          <a:prstGeom prst="flowChartConnector">
+            <a:avLst/>
+          </a:prstGeom>
+          <a:ln>
+            <a:prstDash val="dash"/>
+          </a:ln>
+        </p:spPr>
+        <p:style>
+          <a:lnRef idx="2">
+            <a:schemeClr val="accent3"/>
+          </a:lnRef>
+          <a:fillRef idx="1">
+            <a:schemeClr val="lt1"/>
+          </a:fillRef>
+          <a:effectRef idx="0">
+            <a:schemeClr val="accent3"/>
+          </a:effectRef>
+          <a:fontRef idx="minor">
+            <a:schemeClr val="dk1"/>
+          </a:fontRef>
+        </p:style>
+        <p:txBody>
+          <a:bodyPr rtlCol="0" anchor="ctr"/>
+          <a:lstStyle/>
+          <a:p>
+            <a:pPr algn="ctr"/>
+            <a:endParaRPr lang="en-GB" dirty="0">
+              <a:solidFill>
+                <a:schemeClr val="tx1"/>
+              </a:solidFill>
+            </a:endParaRPr>
+          </a:p>
+        </p:txBody>
+      </p:sp>
+      <p:sp>
+        <p:nvSpPr>
+          <p:cNvPr id="14" name="Flowchart: Connector 13">
+            <a:extLst>
+              <a:ext uri="{FF2B5EF4-FFF2-40B4-BE49-F238E27FC236}">
+                <a16:creationId xmlns:a16="http://schemas.microsoft.com/office/drawing/2014/main" id="{8CF41422-689C-4432-6E2D-FA31776E9AE0}"/>
+              </a:ext>
+            </a:extLst>
+          </p:cNvPr>
+          <p:cNvSpPr/>
+          <p:nvPr/>
+        </p:nvSpPr>
+        <p:spPr>
+          <a:xfrm>
+            <a:off x="7153735" y="2438921"/>
+            <a:ext cx="3169009" cy="3328988"/>
+          </a:xfrm>
+          <a:prstGeom prst="flowChartConnector">
+            <a:avLst/>
+          </a:prstGeom>
+          <a:ln>
+            <a:prstDash val="dash"/>
+          </a:ln>
+        </p:spPr>
+        <p:style>
+          <a:lnRef idx="2">
+            <a:schemeClr val="accent3"/>
+          </a:lnRef>
+          <a:fillRef idx="1">
+            <a:schemeClr val="lt1"/>
+          </a:fillRef>
+          <a:effectRef idx="0">
+            <a:schemeClr val="accent3"/>
+          </a:effectRef>
+          <a:fontRef idx="minor">
+            <a:schemeClr val="dk1"/>
+          </a:fontRef>
+        </p:style>
+        <p:txBody>
+          <a:bodyPr rtlCol="0" anchor="ctr"/>
+          <a:lstStyle/>
+          <a:p>
+            <a:pPr algn="ctr"/>
+            <a:endParaRPr lang="en-GB" dirty="0">
+              <a:solidFill>
+                <a:schemeClr val="tx1"/>
+              </a:solidFill>
+            </a:endParaRPr>
+          </a:p>
+        </p:txBody>
+      </p:sp>
+      <p:sp>
+        <p:nvSpPr>
+          <p:cNvPr id="4" name="Oval 3">
+            <a:extLst>
+              <a:ext uri="{FF2B5EF4-FFF2-40B4-BE49-F238E27FC236}">
+                <a16:creationId xmlns:a16="http://schemas.microsoft.com/office/drawing/2014/main" id="{626D0745-02DC-BF81-9B09-AFAF8279DFAF}"/>
+              </a:ext>
+            </a:extLst>
+          </p:cNvPr>
+          <p:cNvSpPr>
+            <a:spLocks noChangeAspect="1"/>
+          </p:cNvSpPr>
+          <p:nvPr/>
+        </p:nvSpPr>
+        <p:spPr>
+          <a:xfrm>
+            <a:off x="9468790" y="2452777"/>
+            <a:ext cx="853954" cy="853954"/>
+          </a:xfrm>
+          <a:prstGeom prst="ellipse">
+            <a:avLst/>
+          </a:prstGeom>
+        </p:spPr>
+        <p:style>
+          <a:lnRef idx="2">
+            <a:schemeClr val="accent1">
+              <a:shade val="15000"/>
+            </a:schemeClr>
+          </a:lnRef>
+          <a:fillRef idx="1">
+            <a:schemeClr val="accent1"/>
+          </a:fillRef>
+          <a:effectRef idx="0">
+            <a:schemeClr val="accent1"/>
+          </a:effectRef>
+          <a:fontRef idx="minor">
+            <a:schemeClr val="lt1"/>
+          </a:fontRef>
+        </p:style>
+        <p:txBody>
+          <a:bodyPr rtlCol="0" anchor="ctr"/>
+          <a:lstStyle/>
+          <a:p>
+            <a:pPr algn="ctr"/>
+            <a:r>
+              <a:rPr lang="en-GB" sz="1400" dirty="0"/>
+              <a:t>data</a:t>
+            </a:r>
+          </a:p>
+        </p:txBody>
+      </p:sp>
+      <p:sp>
+        <p:nvSpPr>
+          <p:cNvPr id="6" name="Star: 24 Points 5">
+            <a:extLst>
+              <a:ext uri="{FF2B5EF4-FFF2-40B4-BE49-F238E27FC236}">
+                <a16:creationId xmlns:a16="http://schemas.microsoft.com/office/drawing/2014/main" id="{836A8180-3AA9-7215-1132-AADF0ABD29F0}"/>
+              </a:ext>
+            </a:extLst>
+          </p:cNvPr>
+          <p:cNvSpPr/>
+          <p:nvPr/>
+        </p:nvSpPr>
+        <p:spPr>
+          <a:xfrm>
+            <a:off x="7970593" y="3249562"/>
+            <a:ext cx="1562470" cy="1562470"/>
+          </a:xfrm>
+          <a:prstGeom prst="star24">
+            <a:avLst/>
+          </a:prstGeom>
+        </p:spPr>
+        <p:style>
+          <a:lnRef idx="2">
+            <a:schemeClr val="accent4">
+              <a:shade val="15000"/>
+            </a:schemeClr>
+          </a:lnRef>
+          <a:fillRef idx="1">
+            <a:schemeClr val="accent4"/>
+          </a:fillRef>
+          <a:effectRef idx="0">
+            <a:schemeClr val="accent4"/>
+          </a:effectRef>
+          <a:fontRef idx="minor">
+            <a:schemeClr val="lt1"/>
+          </a:fontRef>
+        </p:style>
+        <p:txBody>
+          <a:bodyPr rtlCol="0" anchor="ctr"/>
+          <a:lstStyle/>
+          <a:p>
+            <a:pPr algn="ctr"/>
+            <a:r>
+              <a:rPr lang="en-GB" dirty="0">
+                <a:solidFill>
+                  <a:schemeClr val="tx1"/>
+                </a:solidFill>
+              </a:rPr>
+              <a:t>model</a:t>
+            </a:r>
+          </a:p>
+        </p:txBody>
+      </p:sp>
+      <p:sp>
+        <p:nvSpPr>
+          <p:cNvPr id="2" name="Oval 1">
+            <a:extLst>
+              <a:ext uri="{FF2B5EF4-FFF2-40B4-BE49-F238E27FC236}">
+                <a16:creationId xmlns:a16="http://schemas.microsoft.com/office/drawing/2014/main" id="{8EF668D1-BEA7-D690-B28C-A7BAF6D89734}"/>
+              </a:ext>
+            </a:extLst>
+          </p:cNvPr>
+          <p:cNvSpPr/>
+          <p:nvPr/>
+        </p:nvSpPr>
+        <p:spPr>
+          <a:xfrm>
+            <a:off x="2708610" y="3549789"/>
+            <a:ext cx="1134964" cy="1134964"/>
+          </a:xfrm>
+          <a:prstGeom prst="ellipse">
+            <a:avLst/>
+          </a:prstGeom>
+        </p:spPr>
+        <p:style>
+          <a:lnRef idx="2">
+            <a:schemeClr val="accent1">
+              <a:shade val="15000"/>
+            </a:schemeClr>
+          </a:lnRef>
+          <a:fillRef idx="1">
+            <a:schemeClr val="accent1"/>
+          </a:fillRef>
+          <a:effectRef idx="0">
+            <a:schemeClr val="accent1"/>
+          </a:effectRef>
+          <a:fontRef idx="minor">
+            <a:schemeClr val="lt1"/>
+          </a:fontRef>
+        </p:style>
+        <p:txBody>
+          <a:bodyPr rtlCol="0" anchor="ctr"/>
+          <a:lstStyle/>
+          <a:p>
+            <a:pPr algn="ctr"/>
+            <a:r>
+              <a:rPr lang="en-GB" dirty="0"/>
+              <a:t>data</a:t>
+            </a:r>
+          </a:p>
+        </p:txBody>
+      </p:sp>
+      <p:sp>
+        <p:nvSpPr>
+          <p:cNvPr id="3" name="Star: 24 Points 2">
+            <a:extLst>
+              <a:ext uri="{FF2B5EF4-FFF2-40B4-BE49-F238E27FC236}">
+                <a16:creationId xmlns:a16="http://schemas.microsoft.com/office/drawing/2014/main" id="{55698466-9CC3-3F02-5C21-D31DBC5981FE}"/>
+              </a:ext>
+            </a:extLst>
+          </p:cNvPr>
+          <p:cNvSpPr>
+            <a:spLocks noChangeAspect="1"/>
+          </p:cNvSpPr>
+          <p:nvPr/>
+        </p:nvSpPr>
+        <p:spPr>
+          <a:xfrm>
+            <a:off x="3725633" y="2294036"/>
+            <a:ext cx="1134964" cy="1134964"/>
+          </a:xfrm>
+          <a:prstGeom prst="star24">
+            <a:avLst/>
+          </a:prstGeom>
+        </p:spPr>
+        <p:style>
+          <a:lnRef idx="2">
+            <a:schemeClr val="accent4">
+              <a:shade val="15000"/>
+            </a:schemeClr>
+          </a:lnRef>
+          <a:fillRef idx="1">
+            <a:schemeClr val="accent4"/>
+          </a:fillRef>
+          <a:effectRef idx="0">
+            <a:schemeClr val="accent4"/>
+          </a:effectRef>
+          <a:fontRef idx="minor">
+            <a:schemeClr val="lt1"/>
+          </a:fontRef>
+        </p:style>
+        <p:txBody>
+          <a:bodyPr rtlCol="0" anchor="ctr"/>
+          <a:lstStyle/>
+          <a:p>
+            <a:pPr algn="ctr"/>
+            <a:r>
+              <a:rPr lang="en-GB" sz="1200" dirty="0">
+                <a:solidFill>
+                  <a:schemeClr val="tx1"/>
+                </a:solidFill>
+              </a:rPr>
+              <a:t>null</a:t>
+            </a:r>
+          </a:p>
+          <a:p>
+            <a:pPr algn="ctr"/>
+            <a:r>
+              <a:rPr lang="en-GB" sz="1200" dirty="0">
+                <a:solidFill>
+                  <a:schemeClr val="tx1"/>
+                </a:solidFill>
+              </a:rPr>
+              <a:t>model</a:t>
+            </a:r>
+          </a:p>
+        </p:txBody>
+      </p:sp>
+      <p:sp>
+        <p:nvSpPr>
+          <p:cNvPr id="7" name="TextBox 6">
+            <a:extLst>
+              <a:ext uri="{FF2B5EF4-FFF2-40B4-BE49-F238E27FC236}">
+                <a16:creationId xmlns:a16="http://schemas.microsoft.com/office/drawing/2014/main" id="{FC1C410B-2F41-7B63-EB33-499BCF91DFB0}"/>
+              </a:ext>
+            </a:extLst>
+          </p:cNvPr>
+          <p:cNvSpPr txBox="1"/>
+          <p:nvPr/>
+        </p:nvSpPr>
+        <p:spPr>
+          <a:xfrm>
+            <a:off x="1971497" y="5865771"/>
+            <a:ext cx="3169009" cy="646331"/>
+          </a:xfrm>
+          <a:prstGeom prst="rect">
+            <a:avLst/>
+          </a:prstGeom>
+          <a:noFill/>
+        </p:spPr>
+        <p:txBody>
+          <a:bodyPr wrap="none" rtlCol="0">
+            <a:spAutoFit/>
+          </a:bodyPr>
+          <a:lstStyle/>
+          <a:p>
+            <a:r>
+              <a:rPr lang="en-GB" dirty="0"/>
+              <a:t>Centred on P[data | null model]</a:t>
+            </a:r>
+          </a:p>
+          <a:p>
+            <a:r>
+              <a:rPr lang="en-GB" dirty="0"/>
+              <a:t>Data is fixed</a:t>
+            </a:r>
+          </a:p>
+        </p:txBody>
+      </p:sp>
+      <p:sp>
+        <p:nvSpPr>
+          <p:cNvPr id="8" name="TextBox 7">
+            <a:extLst>
+              <a:ext uri="{FF2B5EF4-FFF2-40B4-BE49-F238E27FC236}">
+                <a16:creationId xmlns:a16="http://schemas.microsoft.com/office/drawing/2014/main" id="{4E335DFD-B56E-785B-B576-7EE8CF0C6522}"/>
+              </a:ext>
+            </a:extLst>
+          </p:cNvPr>
+          <p:cNvSpPr txBox="1"/>
+          <p:nvPr/>
+        </p:nvSpPr>
+        <p:spPr>
+          <a:xfrm>
+            <a:off x="7153735" y="5865770"/>
+            <a:ext cx="4067332" cy="923330"/>
+          </a:xfrm>
+          <a:prstGeom prst="rect">
+            <a:avLst/>
+          </a:prstGeom>
+          <a:noFill/>
+        </p:spPr>
+        <p:txBody>
+          <a:bodyPr wrap="none" rtlCol="0">
+            <a:spAutoFit/>
+          </a:bodyPr>
+          <a:lstStyle/>
+          <a:p>
+            <a:r>
+              <a:rPr lang="en-GB" dirty="0"/>
+              <a:t>Centred on P[model | data] (Bayes’ rule)</a:t>
+            </a:r>
+          </a:p>
+          <a:p>
+            <a:r>
+              <a:rPr lang="en-GB" dirty="0"/>
+              <a:t>Data &amp; observation process are uncertain</a:t>
+            </a:r>
+          </a:p>
+          <a:p>
+            <a:endParaRPr lang="en-GB" dirty="0"/>
+          </a:p>
+        </p:txBody>
+      </p:sp>
+      <p:sp>
+        <p:nvSpPr>
+          <p:cNvPr id="9" name="TextBox 8">
+            <a:extLst>
+              <a:ext uri="{FF2B5EF4-FFF2-40B4-BE49-F238E27FC236}">
+                <a16:creationId xmlns:a16="http://schemas.microsoft.com/office/drawing/2014/main" id="{AE0148EB-ACD9-F850-AC85-1EBA37EB86F9}"/>
+              </a:ext>
+            </a:extLst>
+          </p:cNvPr>
+          <p:cNvSpPr txBox="1"/>
+          <p:nvPr/>
+        </p:nvSpPr>
+        <p:spPr>
+          <a:xfrm>
+            <a:off x="2348331" y="1492530"/>
+            <a:ext cx="1821140" cy="369332"/>
+          </a:xfrm>
+          <a:prstGeom prst="rect">
+            <a:avLst/>
+          </a:prstGeom>
+          <a:noFill/>
+        </p:spPr>
+        <p:txBody>
+          <a:bodyPr wrap="none" rtlCol="0">
+            <a:spAutoFit/>
+          </a:bodyPr>
+          <a:lstStyle/>
+          <a:p>
+            <a:r>
+              <a:rPr lang="en-GB" dirty="0"/>
+              <a:t>Data-centric view</a:t>
+            </a:r>
+          </a:p>
+        </p:txBody>
+      </p:sp>
+      <p:sp>
+        <p:nvSpPr>
+          <p:cNvPr id="10" name="TextBox 9">
+            <a:extLst>
+              <a:ext uri="{FF2B5EF4-FFF2-40B4-BE49-F238E27FC236}">
+                <a16:creationId xmlns:a16="http://schemas.microsoft.com/office/drawing/2014/main" id="{9CEF28E2-D044-C9A4-87DF-124765DAE110}"/>
+              </a:ext>
+            </a:extLst>
+          </p:cNvPr>
+          <p:cNvSpPr txBox="1"/>
+          <p:nvPr/>
+        </p:nvSpPr>
+        <p:spPr>
+          <a:xfrm>
+            <a:off x="7132840" y="1416670"/>
+            <a:ext cx="2047292" cy="369332"/>
+          </a:xfrm>
+          <a:prstGeom prst="rect">
+            <a:avLst/>
+          </a:prstGeom>
+          <a:noFill/>
+        </p:spPr>
+        <p:txBody>
+          <a:bodyPr wrap="none" rtlCol="0">
+            <a:spAutoFit/>
+          </a:bodyPr>
+          <a:lstStyle/>
+          <a:p>
+            <a:r>
+              <a:rPr lang="en-GB" dirty="0"/>
+              <a:t>Model-centric view </a:t>
+            </a:r>
+          </a:p>
+        </p:txBody>
+      </p:sp>
+      <p:sp>
+        <p:nvSpPr>
+          <p:cNvPr id="11" name="Flowchart: Connector 10">
+            <a:extLst>
+              <a:ext uri="{FF2B5EF4-FFF2-40B4-BE49-F238E27FC236}">
+                <a16:creationId xmlns:a16="http://schemas.microsoft.com/office/drawing/2014/main" id="{7742BD42-2C88-0D11-55A7-D6167DF574D7}"/>
+              </a:ext>
+            </a:extLst>
+          </p:cNvPr>
+          <p:cNvSpPr/>
+          <p:nvPr/>
+        </p:nvSpPr>
+        <p:spPr>
+          <a:xfrm>
+            <a:off x="9086757" y="2091764"/>
+            <a:ext cx="1618019" cy="1575979"/>
+          </a:xfrm>
+          <a:prstGeom prst="flowChartConnector">
+            <a:avLst/>
+          </a:prstGeom>
+          <a:noFill/>
+          <a:ln>
+            <a:prstDash val="dash"/>
+          </a:ln>
+        </p:spPr>
+        <p:style>
+          <a:lnRef idx="2">
+            <a:schemeClr val="accent3"/>
+          </a:lnRef>
+          <a:fillRef idx="1">
+            <a:schemeClr val="lt1"/>
+          </a:fillRef>
+          <a:effectRef idx="0">
+            <a:schemeClr val="accent3"/>
+          </a:effectRef>
+          <a:fontRef idx="minor">
+            <a:schemeClr val="dk1"/>
+          </a:fontRef>
+        </p:style>
+        <p:txBody>
+          <a:bodyPr rtlCol="0" anchor="ctr"/>
+          <a:lstStyle/>
+          <a:p>
+            <a:pPr algn="ctr"/>
+            <a:endParaRPr lang="en-GB" dirty="0">
+              <a:solidFill>
+                <a:schemeClr val="tx1"/>
+              </a:solidFill>
+            </a:endParaRPr>
+          </a:p>
+        </p:txBody>
+      </p:sp>
+      <p:sp>
+        <p:nvSpPr>
+          <p:cNvPr id="12" name="Star: 24 Points 11">
+            <a:extLst>
+              <a:ext uri="{FF2B5EF4-FFF2-40B4-BE49-F238E27FC236}">
+                <a16:creationId xmlns:a16="http://schemas.microsoft.com/office/drawing/2014/main" id="{BE84A356-6E08-0897-DBA2-5ED2E01C279B}"/>
+              </a:ext>
+            </a:extLst>
+          </p:cNvPr>
+          <p:cNvSpPr>
+            <a:spLocks noChangeAspect="1"/>
+          </p:cNvSpPr>
+          <p:nvPr/>
+        </p:nvSpPr>
+        <p:spPr>
+          <a:xfrm>
+            <a:off x="9992249" y="3076631"/>
+            <a:ext cx="1425053" cy="704738"/>
+          </a:xfrm>
+          <a:prstGeom prst="star24">
+            <a:avLst/>
+          </a:prstGeom>
+        </p:spPr>
+        <p:style>
+          <a:lnRef idx="2">
+            <a:schemeClr val="accent4">
+              <a:shade val="15000"/>
+            </a:schemeClr>
+          </a:lnRef>
+          <a:fillRef idx="1">
+            <a:schemeClr val="accent4"/>
+          </a:fillRef>
+          <a:effectRef idx="0">
+            <a:schemeClr val="accent4"/>
+          </a:effectRef>
+          <a:fontRef idx="minor">
+            <a:schemeClr val="lt1"/>
+          </a:fontRef>
+        </p:style>
+        <p:txBody>
+          <a:bodyPr rtlCol="0" anchor="ctr"/>
+          <a:lstStyle/>
+          <a:p>
+            <a:pPr algn="ctr"/>
+            <a:r>
+              <a:rPr lang="en-GB" sz="1400" dirty="0" err="1">
+                <a:solidFill>
+                  <a:schemeClr val="tx1"/>
+                </a:solidFill>
+              </a:rPr>
+              <a:t>obs</a:t>
+            </a:r>
+            <a:endParaRPr lang="en-GB" sz="1400" dirty="0">
+              <a:solidFill>
+                <a:schemeClr val="tx1"/>
+              </a:solidFill>
+            </a:endParaRPr>
+          </a:p>
+          <a:p>
+            <a:pPr algn="ctr"/>
+            <a:r>
+              <a:rPr lang="en-GB" sz="1400" dirty="0">
+                <a:solidFill>
+                  <a:schemeClr val="tx1"/>
+                </a:solidFill>
+              </a:rPr>
+              <a:t>process</a:t>
+            </a:r>
+          </a:p>
+        </p:txBody>
+      </p:sp>
+    </p:spTree>
+    <p:extLst>
+      <p:ext uri="{BB962C8B-B14F-4D97-AF65-F5344CB8AC3E}">
+        <p14:creationId xmlns:p14="http://schemas.microsoft.com/office/powerpoint/2010/main" val="1558253119"/>
+      </p:ext>
+    </p:extLst>
+  </p:cSld>
+  <p:clrMapOvr>
+    <a:masterClrMapping/>
+  </p:clrMapOvr>
+</p:sld>
+</file>
+
+<file path=ppt/slides/slide4.xml><?xml version="1.0" encoding="utf-8"?>
+<p:sld xmlns:a="http://schemas.openxmlformats.org/drawingml/2006/main" xmlns:r="http://schemas.openxmlformats.org/officeDocument/2006/relationships" xmlns:p="http://schemas.openxmlformats.org/presentationml/2006/main">
+  <p:cSld>
+    <p:spTree>
+      <p:nvGrpSpPr>
+        <p:cNvPr id="1" name=""/>
+        <p:cNvGrpSpPr/>
+        <p:nvPr/>
+      </p:nvGrpSpPr>
+      <p:grpSpPr>
+        <a:xfrm>
+          <a:off x="0" y="0"/>
+          <a:ext cx="0" cy="0"/>
+          <a:chOff x="0" y="0"/>
+          <a:chExt cx="0" cy="0"/>
+        </a:xfrm>
+      </p:grpSpPr>
+      <p:pic>
+        <p:nvPicPr>
+          <p:cNvPr id="5" name="Picture 4">
+            <a:extLst>
+              <a:ext uri="{FF2B5EF4-FFF2-40B4-BE49-F238E27FC236}">
+                <a16:creationId xmlns:a16="http://schemas.microsoft.com/office/drawing/2014/main" id="{86C2106B-740E-3FF7-8EC3-00D8646D3DF9}"/>
+              </a:ext>
+            </a:extLst>
+          </p:cNvPr>
+          <p:cNvPicPr>
+            <a:picLocks noChangeAspect="1"/>
+          </p:cNvPicPr>
+          <p:nvPr/>
+        </p:nvPicPr>
+        <p:blipFill>
+          <a:blip r:embed="rId2">
+            <a:extLst>
+              <a:ext uri="{28A0092B-C50C-407E-A947-70E740481C1C}">
+                <a14:useLocalDpi xmlns:a14="http://schemas.microsoft.com/office/drawing/2010/main" val="0"/>
+              </a:ext>
+            </a:extLst>
+          </a:blip>
+          <a:stretch>
+            <a:fillRect/>
+          </a:stretch>
+        </p:blipFill>
+        <p:spPr>
+          <a:xfrm>
+            <a:off x="0" y="0"/>
+            <a:ext cx="12192000" cy="6858000"/>
+          </a:xfrm>
+          <a:prstGeom prst="rect">
+            <a:avLst/>
+          </a:prstGeom>
+        </p:spPr>
+      </p:pic>
+      <p:pic>
+        <p:nvPicPr>
+          <p:cNvPr id="7" name="Picture 6">
+            <a:extLst>
+              <a:ext uri="{FF2B5EF4-FFF2-40B4-BE49-F238E27FC236}">
+                <a16:creationId xmlns:a16="http://schemas.microsoft.com/office/drawing/2014/main" id="{817B720B-F08D-8BD1-0FAD-68BFD82E398C}"/>
+              </a:ext>
+            </a:extLst>
+          </p:cNvPr>
+          <p:cNvPicPr>
+            <a:picLocks noChangeAspect="1"/>
+          </p:cNvPicPr>
+          <p:nvPr/>
+        </p:nvPicPr>
+        <p:blipFill>
+          <a:blip r:embed="rId3">
+            <a:extLst>
+              <a:ext uri="{28A0092B-C50C-407E-A947-70E740481C1C}">
+                <a14:useLocalDpi xmlns:a14="http://schemas.microsoft.com/office/drawing/2010/main" val="0"/>
+              </a:ext>
+            </a:extLst>
+          </a:blip>
+          <a:stretch>
+            <a:fillRect/>
+          </a:stretch>
+        </p:blipFill>
+        <p:spPr>
+          <a:xfrm>
+            <a:off x="8077200" y="4114800"/>
+            <a:ext cx="4114800" cy="2743200"/>
+          </a:xfrm>
+          <a:prstGeom prst="rect">
+            <a:avLst/>
+          </a:prstGeom>
+        </p:spPr>
+      </p:pic>
+    </p:spTree>
+    <p:extLst>
+      <p:ext uri="{BB962C8B-B14F-4D97-AF65-F5344CB8AC3E}">
+        <p14:creationId xmlns:p14="http://schemas.microsoft.com/office/powerpoint/2010/main" val="140351694"/>
+      </p:ext>
+    </p:extLst>
+  </p:cSld>
+  <p:clrMapOvr>
+    <a:masterClrMapping/>
+  </p:clrMapOvr>
+</p:sld>
+</file>
+
 <file path=ppt/theme/theme1.xml><?xml version="1.0" encoding="utf-8"?>
 <a:theme xmlns:a="http://schemas.openxmlformats.org/drawingml/2006/main" name="Office Theme">
   <a:themeElements>

</xml_diff>

<commit_message>
cut to 6 slides
</commit_message>
<xml_diff>
--- a/images/copernican_revolution.pptx
+++ b/images/copernican_revolution.pptx
@@ -5594,74 +5594,101 @@
           </a:p>
         </p:txBody>
       </p:sp>
-      <p:sp>
-        <p:nvSpPr>
-          <p:cNvPr id="12" name="Star: 24 Points 11">
-            <a:extLst>
-              <a:ext uri="{FF2B5EF4-FFF2-40B4-BE49-F238E27FC236}">
-                <a16:creationId xmlns:a16="http://schemas.microsoft.com/office/drawing/2014/main" id="{BE84A356-6E08-0897-DBA2-5ED2E01C279B}"/>
-              </a:ext>
-            </a:extLst>
-          </p:cNvPr>
-          <p:cNvSpPr>
-            <a:spLocks noChangeAspect="1"/>
-          </p:cNvSpPr>
+      <p:pic>
+        <p:nvPicPr>
+          <p:cNvPr id="15" name="Picture 14">
+            <a:extLst>
+              <a:ext uri="{FF2B5EF4-FFF2-40B4-BE49-F238E27FC236}">
+                <a16:creationId xmlns:a16="http://schemas.microsoft.com/office/drawing/2014/main" id="{79FA3E7D-7A69-7062-746A-CECE61BFDFF3}"/>
+              </a:ext>
+            </a:extLst>
+          </p:cNvPr>
+          <p:cNvPicPr>
+            <a:picLocks noChangeAspect="1"/>
+          </p:cNvPicPr>
           <p:nvPr/>
-        </p:nvSpPr>
-        <p:spPr>
-          <a:xfrm>
-            <a:off x="9992249" y="3076631"/>
-            <a:ext cx="1425053" cy="704738"/>
-          </a:xfrm>
-          <a:prstGeom prst="star24">
+        </p:nvPicPr>
+        <p:blipFill>
+          <a:blip r:embed="rId2">
+            <a:extLst>
+              <a:ext uri="{BEBA8EAE-BF5A-486C-A8C5-ECC9F3942E4B}">
+                <a14:imgProps xmlns:a14="http://schemas.microsoft.com/office/drawing/2010/main">
+                  <a14:imgLayer r:embed="rId3">
+                    <a14:imgEffect>
+                      <a14:colorTemperature colorTemp="2520"/>
+                    </a14:imgEffect>
+                    <a14:imgEffect>
+                      <a14:saturation sat="0"/>
+                    </a14:imgEffect>
+                  </a14:imgLayer>
+                </a14:imgProps>
+              </a:ext>
+              <a:ext uri="{28A0092B-C50C-407E-A947-70E740481C1C}">
+                <a14:useLocalDpi xmlns:a14="http://schemas.microsoft.com/office/drawing/2010/main" val="0"/>
+              </a:ext>
+              <a:ext uri="{837473B0-CC2E-450A-ABE3-18F120FF3D39}">
+                <a1611:picAttrSrcUrl xmlns:a1611="http://schemas.microsoft.com/office/drawing/2016/11/main" r:id="rId4"/>
+              </a:ext>
+            </a:extLst>
+          </a:blip>
+          <a:stretch>
+            <a:fillRect/>
+          </a:stretch>
+        </p:blipFill>
+        <p:spPr>
+          <a:xfrm>
+            <a:off x="10206503" y="2999372"/>
+            <a:ext cx="996545" cy="996545"/>
+          </a:xfrm>
+          <a:prstGeom prst="rect">
             <a:avLst/>
           </a:prstGeom>
         </p:spPr>
-        <p:style>
-          <a:lnRef idx="2">
-            <a:schemeClr val="accent4">
-              <a:shade val="15000"/>
-            </a:schemeClr>
-          </a:lnRef>
-          <a:fillRef idx="1">
-            <a:schemeClr val="accent4"/>
-          </a:fillRef>
-          <a:effectRef idx="0">
-            <a:schemeClr val="accent4"/>
-          </a:effectRef>
-          <a:fontRef idx="minor">
-            <a:schemeClr val="lt1"/>
-          </a:fontRef>
-        </p:style>
-        <p:txBody>
-          <a:bodyPr rtlCol="0" anchor="ctr"/>
+      </p:pic>
+      <p:sp>
+        <p:nvSpPr>
+          <p:cNvPr id="16" name="TextBox 15">
+            <a:extLst>
+              <a:ext uri="{FF2B5EF4-FFF2-40B4-BE49-F238E27FC236}">
+                <a16:creationId xmlns:a16="http://schemas.microsoft.com/office/drawing/2014/main" id="{BEA25FDC-213B-DF50-8509-21C44DE07689}"/>
+              </a:ext>
+            </a:extLst>
+          </p:cNvPr>
+          <p:cNvSpPr txBox="1"/>
+          <p:nvPr/>
+        </p:nvSpPr>
+        <p:spPr>
+          <a:xfrm>
+            <a:off x="10256030" y="3107467"/>
+            <a:ext cx="897490" cy="923330"/>
+          </a:xfrm>
+          <a:prstGeom prst="rect">
+            <a:avLst/>
+          </a:prstGeom>
+          <a:noFill/>
+        </p:spPr>
+        <p:txBody>
+          <a:bodyPr wrap="none" rtlCol="0">
+            <a:spAutoFit/>
+          </a:bodyPr>
           <a:lstStyle/>
           <a:p>
             <a:pPr algn="ctr"/>
             <a:r>
-              <a:rPr lang="en-GB" sz="1400" dirty="0" err="1">
-                <a:solidFill>
-                  <a:schemeClr val="tx1"/>
-                </a:solidFill>
-              </a:rPr>
+              <a:rPr lang="en-GB" dirty="0" err="1"/>
               <a:t>obs</a:t>
             </a:r>
-            <a:endParaRPr lang="en-GB" sz="1400" dirty="0">
-              <a:solidFill>
-                <a:schemeClr val="tx1"/>
-              </a:solidFill>
-            </a:endParaRPr>
+            <a:endParaRPr lang="en-GB" dirty="0"/>
           </a:p>
           <a:p>
             <a:pPr algn="ctr"/>
             <a:r>
-              <a:rPr lang="en-GB" sz="1400" dirty="0">
-                <a:solidFill>
-                  <a:schemeClr val="tx1"/>
-                </a:solidFill>
-              </a:rPr>
+              <a:rPr lang="en-GB" dirty="0"/>
               <a:t>process</a:t>
             </a:r>
+          </a:p>
+          <a:p>
+            <a:endParaRPr lang="en-GB" dirty="0"/>
           </a:p>
         </p:txBody>
       </p:sp>

</xml_diff>